<commit_message>
Polish presentation chart images
Replaced the 4 embedded chart images (Q1 choropleth, Q2 scatter, Q5
bubble, Q10 K-Means) with presentation-specific versions: larger fonts,
no redundant chart titles (slide title already covers it), cleaner
spines/gridlines, bigger markers, and richer color use throughout —
the Q2 scatter now colors points by region (adds both visual interest
and a legend), the choropleth uses a deeper/more saturated blue ramp,
and the bubble/cluster charts use bolder marker styling. Same CVD-safe
hues as before, just applied with more visual polish for a slide
context instead of notebook-export defaults.

Verified by re-rendering the 4 affected slides and checking them in
their actual slide layout, not just as standalone images.

Co-Authored-By: Claude Sonnet 5 <noreply@anthropic.com>
</commit_message>
<xml_diff>
--- a/presentation/AI_Data_Center_Sustainability_Presentation.pptx
+++ b/presentation/AI_Data_Center_Sustainability_Presentation.pptx
@@ -3492,7 +3492,7 @@
       </p:sp>
       <p:pic>
         <p:nvPicPr>
-          <p:cNvPr id="4" name="Picture 3" descr="slide5_choropleth_cvd.png"/>
+          <p:cNvPr id="4" name="Picture 3" descr="pres_choropleth.png"/>
           <p:cNvPicPr>
             <a:picLocks noChangeAspect="1"/>
           </p:cNvPicPr>
@@ -3506,8 +3506,8 @@
         </p:blipFill>
         <p:spPr>
           <a:xfrm>
-            <a:off x="548640" y="1910080"/>
-            <a:ext cx="6949440" cy="3860800"/>
+            <a:off x="548640" y="1787236"/>
+            <a:ext cx="6949440" cy="4106487"/>
           </a:xfrm>
           <a:prstGeom prst="rect">
             <a:avLst/>
@@ -3815,7 +3815,7 @@
       </p:sp>
       <p:pic>
         <p:nvPicPr>
-          <p:cNvPr id="4" name="Picture 3" descr="q2.png"/>
+          <p:cNvPr id="4" name="Picture 3" descr="pres_q2.png"/>
           <p:cNvPicPr>
             <a:picLocks noChangeAspect="1"/>
           </p:cNvPicPr>
@@ -3829,8 +3829,8 @@
         </p:blipFill>
         <p:spPr>
           <a:xfrm>
-            <a:off x="954483" y="1554480"/>
-            <a:ext cx="6137753" cy="4572000"/>
+            <a:off x="548640" y="1566118"/>
+            <a:ext cx="6949440" cy="4548724"/>
           </a:xfrm>
           <a:prstGeom prst="rect">
             <a:avLst/>
@@ -4106,7 +4106,7 @@
       </p:sp>
       <p:pic>
         <p:nvPicPr>
-          <p:cNvPr id="4" name="Picture 3" descr="slide7_balance_cvd.png"/>
+          <p:cNvPr id="4" name="Picture 3" descr="pres_q5.png"/>
           <p:cNvPicPr>
             <a:picLocks noChangeAspect="1"/>
           </p:cNvPicPr>
@@ -4120,8 +4120,8 @@
         </p:blipFill>
         <p:spPr>
           <a:xfrm>
-            <a:off x="594360" y="1554480"/>
-            <a:ext cx="6858000" cy="4572000"/>
+            <a:off x="548640" y="1566118"/>
+            <a:ext cx="6949440" cy="4548724"/>
           </a:xfrm>
           <a:prstGeom prst="rect">
             <a:avLst/>
@@ -4397,7 +4397,7 @@
       </p:sp>
       <p:pic>
         <p:nvPicPr>
-          <p:cNvPr id="4" name="Picture 3" descr="v3_cell34.png"/>
+          <p:cNvPr id="4" name="Picture 3" descr="pres_kmeans.png"/>
           <p:cNvPicPr>
             <a:picLocks noChangeAspect="1"/>
           </p:cNvPicPr>
@@ -4411,8 +4411,8 @@
         </p:blipFill>
         <p:spPr>
           <a:xfrm>
-            <a:off x="744755" y="1554480"/>
-            <a:ext cx="6557210" cy="4572000"/>
+            <a:off x="548640" y="1566118"/>
+            <a:ext cx="6949440" cy="4548724"/>
           </a:xfrm>
           <a:prstGeom prst="rect">
             <a:avLst/>

</xml_diff>